<commit_message>
Complete Milestone 3 and Milestone 4 implementation
</commit_message>
<xml_diff>
--- a/documentation/Milestone-2.pptx
+++ b/documentation/Milestone-2.pptx
@@ -203,7 +203,7 @@
           <a:p>
             <a:fld id="{A59E1E58-E463-458F-8806-FE7AB0337E9F}" type="datetimeFigureOut">
               <a:rPr lang="en-IN" smtClean="0"/>
-              <a:t>13-08-2026</a:t>
+              <a:t>28-08-2026</a:t>
             </a:fld>
             <a:endParaRPr lang="en-IN"/>
           </a:p>
@@ -772,7 +772,7 @@
           <a:p>
             <a:fld id="{EA3A229A-1D63-49FA-95F1-4B54D4E9751A}" type="datetimeFigureOut">
               <a:rPr lang="en-IN" smtClean="0"/>
-              <a:t>13-08-2026</a:t>
+              <a:t>28-08-2026</a:t>
             </a:fld>
             <a:endParaRPr lang="en-IN"/>
           </a:p>
@@ -1059,7 +1059,7 @@
           <a:p>
             <a:fld id="{EA3A229A-1D63-49FA-95F1-4B54D4E9751A}" type="datetimeFigureOut">
               <a:rPr lang="en-IN" smtClean="0"/>
-              <a:t>13-08-2026</a:t>
+              <a:t>28-08-2026</a:t>
             </a:fld>
             <a:endParaRPr lang="en-IN"/>
           </a:p>
@@ -1251,7 +1251,7 @@
           <a:p>
             <a:fld id="{EA3A229A-1D63-49FA-95F1-4B54D4E9751A}" type="datetimeFigureOut">
               <a:rPr lang="en-IN" smtClean="0"/>
-              <a:t>13-08-2026</a:t>
+              <a:t>28-08-2026</a:t>
             </a:fld>
             <a:endParaRPr lang="en-IN"/>
           </a:p>
@@ -1512,7 +1512,7 @@
           <a:p>
             <a:fld id="{EA3A229A-1D63-49FA-95F1-4B54D4E9751A}" type="datetimeFigureOut">
               <a:rPr lang="en-IN" smtClean="0"/>
-              <a:t>13-08-2026</a:t>
+              <a:t>28-08-2026</a:t>
             </a:fld>
             <a:endParaRPr lang="en-IN"/>
           </a:p>
@@ -1936,7 +1936,7 @@
           <a:p>
             <a:fld id="{EA3A229A-1D63-49FA-95F1-4B54D4E9751A}" type="datetimeFigureOut">
               <a:rPr lang="en-IN" smtClean="0"/>
-              <a:t>13-08-2026</a:t>
+              <a:t>28-08-2026</a:t>
             </a:fld>
             <a:endParaRPr lang="en-IN"/>
           </a:p>
@@ -2482,7 +2482,7 @@
           <a:p>
             <a:fld id="{EA3A229A-1D63-49FA-95F1-4B54D4E9751A}" type="datetimeFigureOut">
               <a:rPr lang="en-IN" smtClean="0"/>
-              <a:t>13-08-2026</a:t>
+              <a:t>28-08-2026</a:t>
             </a:fld>
             <a:endParaRPr lang="en-IN"/>
           </a:p>
@@ -3322,7 +3322,7 @@
           <a:p>
             <a:fld id="{EA3A229A-1D63-49FA-95F1-4B54D4E9751A}" type="datetimeFigureOut">
               <a:rPr lang="en-IN" smtClean="0"/>
-              <a:t>13-08-2026</a:t>
+              <a:t>28-08-2026</a:t>
             </a:fld>
             <a:endParaRPr lang="en-IN"/>
           </a:p>
@@ -3492,7 +3492,7 @@
           <a:p>
             <a:fld id="{EA3A229A-1D63-49FA-95F1-4B54D4E9751A}" type="datetimeFigureOut">
               <a:rPr lang="en-IN" smtClean="0"/>
-              <a:t>13-08-2026</a:t>
+              <a:t>28-08-2026</a:t>
             </a:fld>
             <a:endParaRPr lang="en-IN"/>
           </a:p>
@@ -3676,7 +3676,7 @@
           <a:p>
             <a:fld id="{EA3A229A-1D63-49FA-95F1-4B54D4E9751A}" type="datetimeFigureOut">
               <a:rPr lang="en-IN" smtClean="0"/>
-              <a:t>13-08-2026</a:t>
+              <a:t>28-08-2026</a:t>
             </a:fld>
             <a:endParaRPr lang="en-IN"/>
           </a:p>
@@ -3846,7 +3846,7 @@
           <a:p>
             <a:fld id="{EA3A229A-1D63-49FA-95F1-4B54D4E9751A}" type="datetimeFigureOut">
               <a:rPr lang="en-IN" smtClean="0"/>
-              <a:t>13-08-2026</a:t>
+              <a:t>28-08-2026</a:t>
             </a:fld>
             <a:endParaRPr lang="en-IN"/>
           </a:p>
@@ -4094,7 +4094,7 @@
           <a:p>
             <a:fld id="{EA3A229A-1D63-49FA-95F1-4B54D4E9751A}" type="datetimeFigureOut">
               <a:rPr lang="en-IN" smtClean="0"/>
-              <a:t>13-08-2026</a:t>
+              <a:t>28-08-2026</a:t>
             </a:fld>
             <a:endParaRPr lang="en-IN"/>
           </a:p>
@@ -4331,7 +4331,7 @@
           <a:p>
             <a:fld id="{EA3A229A-1D63-49FA-95F1-4B54D4E9751A}" type="datetimeFigureOut">
               <a:rPr lang="en-IN" smtClean="0"/>
-              <a:t>13-08-2026</a:t>
+              <a:t>28-08-2026</a:t>
             </a:fld>
             <a:endParaRPr lang="en-IN"/>
           </a:p>
@@ -4704,7 +4704,7 @@
           <a:p>
             <a:fld id="{EA3A229A-1D63-49FA-95F1-4B54D4E9751A}" type="datetimeFigureOut">
               <a:rPr lang="en-IN" smtClean="0"/>
-              <a:t>13-08-2026</a:t>
+              <a:t>28-08-2026</a:t>
             </a:fld>
             <a:endParaRPr lang="en-IN"/>
           </a:p>
@@ -4822,7 +4822,7 @@
           <a:p>
             <a:fld id="{EA3A229A-1D63-49FA-95F1-4B54D4E9751A}" type="datetimeFigureOut">
               <a:rPr lang="en-IN" smtClean="0"/>
-              <a:t>13-08-2026</a:t>
+              <a:t>28-08-2026</a:t>
             </a:fld>
             <a:endParaRPr lang="en-IN"/>
           </a:p>
@@ -4917,7 +4917,7 @@
           <a:p>
             <a:fld id="{EA3A229A-1D63-49FA-95F1-4B54D4E9751A}" type="datetimeFigureOut">
               <a:rPr lang="en-IN" smtClean="0"/>
-              <a:t>13-08-2026</a:t>
+              <a:t>28-08-2026</a:t>
             </a:fld>
             <a:endParaRPr lang="en-IN"/>
           </a:p>
@@ -5168,7 +5168,7 @@
           <a:p>
             <a:fld id="{EA3A229A-1D63-49FA-95F1-4B54D4E9751A}" type="datetimeFigureOut">
               <a:rPr lang="en-IN" smtClean="0"/>
-              <a:t>13-08-2026</a:t>
+              <a:t>28-08-2026</a:t>
             </a:fld>
             <a:endParaRPr lang="en-IN"/>
           </a:p>
@@ -5455,7 +5455,7 @@
           <a:p>
             <a:fld id="{EA3A229A-1D63-49FA-95F1-4B54D4E9751A}" type="datetimeFigureOut">
               <a:rPr lang="en-IN" smtClean="0"/>
-              <a:t>13-08-2026</a:t>
+              <a:t>28-08-2026</a:t>
             </a:fld>
             <a:endParaRPr lang="en-IN"/>
           </a:p>
@@ -5668,7 +5668,7 @@
           <a:p>
             <a:fld id="{EA3A229A-1D63-49FA-95F1-4B54D4E9751A}" type="datetimeFigureOut">
               <a:rPr lang="en-IN" smtClean="0"/>
-              <a:t>13-08-2026</a:t>
+              <a:t>28-08-2026</a:t>
             </a:fld>
             <a:endParaRPr lang="en-IN"/>
           </a:p>
@@ -6622,8 +6622,8 @@
         </p:blipFill>
         <p:spPr>
           <a:xfrm>
-            <a:off x="5737632" y="3622160"/>
-            <a:ext cx="6189662" cy="2980897"/>
+            <a:off x="5078413" y="1989239"/>
+            <a:ext cx="6189662" cy="2422322"/>
           </a:xfrm>
           <a:prstGeom prst="rect">
             <a:avLst/>
@@ -6924,6 +6924,44 @@
           </a:p>
         </p:txBody>
       </p:sp>
+      <p:pic>
+        <p:nvPicPr>
+          <p:cNvPr id="12" name="Content Placeholder 11">
+            <a:extLst>
+              <a:ext uri="{FF2B5EF4-FFF2-40B4-BE49-F238E27FC236}">
+                <a16:creationId xmlns:a16="http://schemas.microsoft.com/office/drawing/2014/main" id="{FB04C697-FE76-27E8-385A-23DF4788DB6A}"/>
+              </a:ext>
+            </a:extLst>
+          </p:cNvPr>
+          <p:cNvPicPr>
+            <a:picLocks noGrp="1" noChangeAspect="1"/>
+          </p:cNvPicPr>
+          <p:nvPr>
+            <p:ph sz="half" idx="2"/>
+          </p:nvPr>
+        </p:nvPicPr>
+        <p:blipFill>
+          <a:blip r:embed="rId2">
+            <a:extLst>
+              <a:ext uri="{28A0092B-C50C-407E-A947-70E740481C1C}">
+                <a14:useLocalDpi xmlns:a14="http://schemas.microsoft.com/office/drawing/2010/main" val="0"/>
+              </a:ext>
+            </a:extLst>
+          </a:blip>
+          <a:stretch>
+            <a:fillRect/>
+          </a:stretch>
+        </p:blipFill>
+        <p:spPr>
+          <a:xfrm>
+            <a:off x="6281286" y="1935163"/>
+            <a:ext cx="5369800" cy="1721374"/>
+          </a:xfrm>
+          <a:prstGeom prst="rect">
+            <a:avLst/>
+          </a:prstGeom>
+        </p:spPr>
+      </p:pic>
       <p:sp>
         <p:nvSpPr>
           <p:cNvPr id="5" name="Text Placeholder 4">
@@ -6968,45 +7006,6 @@
           </p:cNvPicPr>
           <p:nvPr>
             <p:ph sz="quarter" idx="4"/>
-          </p:nvPr>
-        </p:nvPicPr>
-        <p:blipFill>
-          <a:blip r:embed="rId2">
-            <a:extLst>
-              <a:ext uri="{28A0092B-C50C-407E-A947-70E740481C1C}">
-                <a14:useLocalDpi xmlns:a14="http://schemas.microsoft.com/office/drawing/2010/main" val="0"/>
-              </a:ext>
-            </a:extLst>
-          </a:blip>
-          <a:srcRect t="291"/>
-          <a:stretch>
-            <a:fillRect/>
-          </a:stretch>
-        </p:blipFill>
-        <p:spPr>
-          <a:xfrm>
-            <a:off x="6281286" y="4094635"/>
-            <a:ext cx="5369801" cy="1721374"/>
-          </a:xfrm>
-          <a:prstGeom prst="rect">
-            <a:avLst/>
-          </a:prstGeom>
-        </p:spPr>
-      </p:pic>
-      <p:pic>
-        <p:nvPicPr>
-          <p:cNvPr id="12" name="Content Placeholder 11">
-            <a:extLst>
-              <a:ext uri="{FF2B5EF4-FFF2-40B4-BE49-F238E27FC236}">
-                <a16:creationId xmlns:a16="http://schemas.microsoft.com/office/drawing/2014/main" id="{FB04C697-FE76-27E8-385A-23DF4788DB6A}"/>
-              </a:ext>
-            </a:extLst>
-          </p:cNvPr>
-          <p:cNvPicPr>
-            <a:picLocks noGrp="1" noChangeAspect="1"/>
-          </p:cNvPicPr>
-          <p:nvPr>
-            <p:ph sz="half" idx="2"/>
           </p:nvPr>
         </p:nvPicPr>
         <p:blipFill>
@@ -7023,8 +7022,8 @@
         </p:blipFill>
         <p:spPr>
           <a:xfrm>
-            <a:off x="6281286" y="1935163"/>
-            <a:ext cx="5369800" cy="1721374"/>
+            <a:off x="6555211" y="4338320"/>
+            <a:ext cx="5095875" cy="1637179"/>
           </a:xfrm>
           <a:prstGeom prst="rect">
             <a:avLst/>

</xml_diff>